<commit_message>
Post Atlantic Canada Updates
</commit_message>
<xml_diff>
--- a/Provincial outreach deck.pptx
+++ b/Provincial outreach deck.pptx
@@ -169,7 +169,9 @@
 <file path=ppt/revisionInfo.xml><?xml version="1.0" encoding="utf-8"?>
 <p1510:revInfo xmlns:a="http://schemas.openxmlformats.org/drawingml/2006/main" xmlns:r="http://schemas.openxmlformats.org/officeDocument/2006/relationships" xmlns:p1510="http://schemas.microsoft.com/office/powerpoint/2015/10/main">
   <p1510:revLst>
-    <p1510:client id="{70E4B27E-261D-47AD-AC98-BD1AA66EE440}" v="424" dt="2025-06-19T00:32:48.037"/>
+    <p1510:client id="{16CA2AFA-978C-92BC-4352-8F7875D747F9}" v="33" dt="2025-06-24T15:09:18.806"/>
+    <p1510:client id="{189F7C93-9685-FD1F-7412-16E9F17F1A6A}" v="139" dt="2025-06-24T12:46:20.988"/>
+    <p1510:client id="{722F6535-3BA9-48BD-A947-3A9369482811}" v="2" dt="2025-06-24T15:12:09.758"/>
   </p1510:revLst>
 </p1510:revInfo>
 </file>
@@ -256,7 +258,7 @@
           <a:p>
             <a:fld id="{372866AB-5879-457F-8F72-7A0AF9BD56BB}" type="datetimeFigureOut">
               <a:rPr lang="en-CA" smtClean="0"/>
-              <a:t>18-Jun-2025</a:t>
+              <a:t>2025-06-24</a:t>
             </a:fld>
             <a:endParaRPr lang="en-CA"/>
           </a:p>
@@ -673,7 +675,7 @@
           <a:p>
             <a:fld id="{17F47CE0-5509-430C-BE72-EA262CB2E4BD}" type="datetimeFigureOut">
               <a:rPr lang="en-CA" smtClean="0"/>
-              <a:t>18-Jun-2025</a:t>
+              <a:t>2025-06-24</a:t>
             </a:fld>
             <a:endParaRPr lang="en-CA"/>
           </a:p>
@@ -926,7 +928,7 @@
             <a:fld id="{1D8BD707-D9CF-40AE-B4C6-C98DA3205C09}" type="datetimeFigureOut">
               <a:rPr lang="en-US" smtClean="0"/>
               <a:pPr/>
-              <a:t>6/18/2025</a:t>
+              <a:t>6/24/2025</a:t>
             </a:fld>
             <a:endParaRPr lang="en-US"/>
           </a:p>
@@ -1091,7 +1093,7 @@
             <a:fld id="{1D8BD707-D9CF-40AE-B4C6-C98DA3205C09}" type="datetimeFigureOut">
               <a:rPr lang="en-US" smtClean="0"/>
               <a:pPr/>
-              <a:t>6/18/2025</a:t>
+              <a:t>6/24/2025</a:t>
             </a:fld>
             <a:endParaRPr lang="en-US"/>
           </a:p>
@@ -1333,7 +1335,7 @@
             <a:fld id="{1D8BD707-D9CF-40AE-B4C6-C98DA3205C09}" type="datetimeFigureOut">
               <a:rPr lang="en-US" smtClean="0"/>
               <a:pPr/>
-              <a:t>6/18/2025</a:t>
+              <a:t>6/24/2025</a:t>
             </a:fld>
             <a:endParaRPr lang="en-US"/>
           </a:p>
@@ -1620,7 +1622,7 @@
             <a:fld id="{1D8BD707-D9CF-40AE-B4C6-C98DA3205C09}" type="datetimeFigureOut">
               <a:rPr lang="en-US" smtClean="0"/>
               <a:pPr/>
-              <a:t>6/18/2025</a:t>
+              <a:t>6/24/2025</a:t>
             </a:fld>
             <a:endParaRPr lang="en-US"/>
           </a:p>
@@ -2041,7 +2043,7 @@
             <a:fld id="{1D8BD707-D9CF-40AE-B4C6-C98DA3205C09}" type="datetimeFigureOut">
               <a:rPr lang="en-US" smtClean="0"/>
               <a:pPr/>
-              <a:t>6/18/2025</a:t>
+              <a:t>6/24/2025</a:t>
             </a:fld>
             <a:endParaRPr lang="en-US"/>
           </a:p>
@@ -2288,7 +2290,7 @@
             <a:fld id="{1D8BD707-D9CF-40AE-B4C6-C98DA3205C09}" type="datetimeFigureOut">
               <a:rPr lang="en-US" smtClean="0"/>
               <a:pPr/>
-              <a:t>6/18/2025</a:t>
+              <a:t>6/24/2025</a:t>
             </a:fld>
             <a:endParaRPr lang="en-US"/>
           </a:p>
@@ -2570,7 +2572,7 @@
             <a:fld id="{1D8BD707-D9CF-40AE-B4C6-C98DA3205C09}" type="datetimeFigureOut">
               <a:rPr lang="en-US" smtClean="0"/>
               <a:pPr/>
-              <a:t>6/18/2025</a:t>
+              <a:t>6/24/2025</a:t>
             </a:fld>
             <a:endParaRPr lang="en-US"/>
           </a:p>
@@ -2986,7 +2988,7 @@
             <a:fld id="{1D8BD707-D9CF-40AE-B4C6-C98DA3205C09}" type="datetimeFigureOut">
               <a:rPr lang="en-US" smtClean="0"/>
               <a:pPr/>
-              <a:t>6/18/2025</a:t>
+              <a:t>6/24/2025</a:t>
             </a:fld>
             <a:endParaRPr lang="en-US"/>
           </a:p>
@@ -3100,7 +3102,7 @@
             <a:fld id="{1D8BD707-D9CF-40AE-B4C6-C98DA3205C09}" type="datetimeFigureOut">
               <a:rPr lang="en-US" smtClean="0"/>
               <a:pPr/>
-              <a:t>6/18/2025</a:t>
+              <a:t>6/24/2025</a:t>
             </a:fld>
             <a:endParaRPr lang="en-US"/>
           </a:p>
@@ -3192,7 +3194,7 @@
             <a:fld id="{1D8BD707-D9CF-40AE-B4C6-C98DA3205C09}" type="datetimeFigureOut">
               <a:rPr lang="en-US" smtClean="0"/>
               <a:pPr/>
-              <a:t>6/18/2025</a:t>
+              <a:t>6/24/2025</a:t>
             </a:fld>
             <a:endParaRPr lang="en-US"/>
           </a:p>
@@ -3376,7 +3378,7 @@
           <a:p>
             <a:fld id="{17F47CE0-5509-430C-BE72-EA262CB2E4BD}" type="datetimeFigureOut">
               <a:rPr lang="en-CA" smtClean="0"/>
-              <a:t>18-Jun-2025</a:t>
+              <a:t>2025-06-24</a:t>
             </a:fld>
             <a:endParaRPr lang="en-CA"/>
           </a:p>
@@ -3664,7 +3666,7 @@
             <a:fld id="{1D8BD707-D9CF-40AE-B4C6-C98DA3205C09}" type="datetimeFigureOut">
               <a:rPr lang="en-US" smtClean="0"/>
               <a:pPr/>
-              <a:t>6/18/2025</a:t>
+              <a:t>6/24/2025</a:t>
             </a:fld>
             <a:endParaRPr lang="en-US"/>
           </a:p>
@@ -3918,7 +3920,7 @@
             <a:fld id="{1D8BD707-D9CF-40AE-B4C6-C98DA3205C09}" type="datetimeFigureOut">
               <a:rPr lang="en-US" smtClean="0"/>
               <a:pPr/>
-              <a:t>6/18/2025</a:t>
+              <a:t>6/24/2025</a:t>
             </a:fld>
             <a:endParaRPr lang="en-US"/>
           </a:p>
@@ -4195,7 +4197,7 @@
             <a:fld id="{1D8BD707-D9CF-40AE-B4C6-C98DA3205C09}" type="datetimeFigureOut">
               <a:rPr lang="en-US" smtClean="0"/>
               <a:pPr/>
-              <a:t>6/18/2025</a:t>
+              <a:t>6/24/2025</a:t>
             </a:fld>
             <a:endParaRPr lang="en-US"/>
           </a:p>
@@ -4444,7 +4446,7 @@
             <a:fld id="{1D8BD707-D9CF-40AE-B4C6-C98DA3205C09}" type="datetimeFigureOut">
               <a:rPr lang="en-US" smtClean="0"/>
               <a:pPr/>
-              <a:t>6/18/2025</a:t>
+              <a:t>6/24/2025</a:t>
             </a:fld>
             <a:endParaRPr lang="en-US"/>
           </a:p>
@@ -4609,7 +4611,7 @@
             <a:fld id="{1D8BD707-D9CF-40AE-B4C6-C98DA3205C09}" type="datetimeFigureOut">
               <a:rPr lang="en-US" smtClean="0"/>
               <a:pPr/>
-              <a:t>6/18/2025</a:t>
+              <a:t>6/24/2025</a:t>
             </a:fld>
             <a:endParaRPr lang="en-US"/>
           </a:p>
@@ -4784,7 +4786,7 @@
             <a:fld id="{1D8BD707-D9CF-40AE-B4C6-C98DA3205C09}" type="datetimeFigureOut">
               <a:rPr lang="en-US" smtClean="0"/>
               <a:pPr/>
-              <a:t>6/18/2025</a:t>
+              <a:t>6/24/2025</a:t>
             </a:fld>
             <a:endParaRPr lang="en-US"/>
           </a:p>
@@ -5044,7 +5046,7 @@
           <a:p>
             <a:fld id="{17F47CE0-5509-430C-BE72-EA262CB2E4BD}" type="datetimeFigureOut">
               <a:rPr lang="en-CA" smtClean="0"/>
-              <a:t>18-Jun-2025</a:t>
+              <a:t>2025-06-24</a:t>
             </a:fld>
             <a:endParaRPr lang="en-CA"/>
           </a:p>
@@ -5312,7 +5314,7 @@
           <a:p>
             <a:fld id="{17F47CE0-5509-430C-BE72-EA262CB2E4BD}" type="datetimeFigureOut">
               <a:rPr lang="en-CA" smtClean="0"/>
-              <a:t>18-Jun-2025</a:t>
+              <a:t>2025-06-24</a:t>
             </a:fld>
             <a:endParaRPr lang="en-CA"/>
           </a:p>
@@ -5727,7 +5729,7 @@
           <a:p>
             <a:fld id="{17F47CE0-5509-430C-BE72-EA262CB2E4BD}" type="datetimeFigureOut">
               <a:rPr lang="en-CA" smtClean="0"/>
-              <a:t>18-Jun-2025</a:t>
+              <a:t>2025-06-24</a:t>
             </a:fld>
             <a:endParaRPr lang="en-CA"/>
           </a:p>
@@ -5869,7 +5871,7 @@
           <a:p>
             <a:fld id="{17F47CE0-5509-430C-BE72-EA262CB2E4BD}" type="datetimeFigureOut">
               <a:rPr lang="en-CA" smtClean="0"/>
-              <a:t>18-Jun-2025</a:t>
+              <a:t>2025-06-24</a:t>
             </a:fld>
             <a:endParaRPr lang="en-CA"/>
           </a:p>
@@ -5982,7 +5984,7 @@
           <a:p>
             <a:fld id="{17F47CE0-5509-430C-BE72-EA262CB2E4BD}" type="datetimeFigureOut">
               <a:rPr lang="en-CA" smtClean="0"/>
-              <a:t>18-Jun-2025</a:t>
+              <a:t>2025-06-24</a:t>
             </a:fld>
             <a:endParaRPr lang="en-CA"/>
           </a:p>
@@ -6295,7 +6297,7 @@
           <a:p>
             <a:fld id="{17F47CE0-5509-430C-BE72-EA262CB2E4BD}" type="datetimeFigureOut">
               <a:rPr lang="en-CA" smtClean="0"/>
-              <a:t>18-Jun-2025</a:t>
+              <a:t>2025-06-24</a:t>
             </a:fld>
             <a:endParaRPr lang="en-CA"/>
           </a:p>
@@ -6584,7 +6586,7 @@
           <a:p>
             <a:fld id="{17F47CE0-5509-430C-BE72-EA262CB2E4BD}" type="datetimeFigureOut">
               <a:rPr lang="en-CA" smtClean="0"/>
-              <a:t>18-Jun-2025</a:t>
+              <a:t>2025-06-24</a:t>
             </a:fld>
             <a:endParaRPr lang="en-CA"/>
           </a:p>
@@ -6863,7 +6865,7 @@
           <a:p>
             <a:fld id="{17F47CE0-5509-430C-BE72-EA262CB2E4BD}" type="datetimeFigureOut">
               <a:rPr lang="en-CA" smtClean="0"/>
-              <a:t>18-Jun-2025</a:t>
+              <a:t>2025-06-24</a:t>
             </a:fld>
             <a:endParaRPr lang="en-CA"/>
           </a:p>
@@ -7412,7 +7414,7 @@
             <a:fld id="{1D8BD707-D9CF-40AE-B4C6-C98DA3205C09}" type="datetimeFigureOut">
               <a:rPr lang="en-US" smtClean="0"/>
               <a:pPr/>
-              <a:t>6/18/2025</a:t>
+              <a:t>6/24/2025</a:t>
             </a:fld>
             <a:endParaRPr lang="en-US"/>
           </a:p>
@@ -11156,7 +11158,7 @@
         <p:spPr>
           <a:xfrm>
             <a:off x="247135" y="1304512"/>
-            <a:ext cx="11034275" cy="5401479"/>
+            <a:ext cx="11034275" cy="5478423"/>
           </a:xfrm>
           <a:prstGeom prst="rect">
             <a:avLst/>
@@ -11178,7 +11180,7 @@
               </a:spcAft>
             </a:pPr>
             <a:r>
-              <a:rPr lang="en-US" sz="3200" b="1">
+              <a:rPr lang="en-US" sz="3200" b="1" dirty="0">
                 <a:solidFill>
                   <a:schemeClr val="accent1"/>
                 </a:solidFill>
@@ -11195,20 +11197,10 @@
               </a:spcAft>
             </a:pPr>
             <a:r>
-              <a:rPr lang="en-US" sz="2000" b="1"/>
+              <a:rPr lang="en-US" sz="2000" b="1" dirty="0"/>
               <a:t>Policy and data circles</a:t>
             </a:r>
-            <a:endParaRPr lang="en-US" sz="2000"/>
-          </a:p>
-          <a:p>
-            <a:pPr marL="342900" indent="-342900" fontAlgn="base">
-              <a:buFont typeface="Arial" panose="020B0604020202020204" pitchFamily="34" charset="0"/>
-              <a:buChar char="•"/>
-            </a:pPr>
-            <a:r>
-              <a:rPr lang="en-US" sz="2000"/>
-              <a:t>In October 2024, invitation sent to CRDCN researchers to opt into data or policy circles. </a:t>
-            </a:r>
+            <a:endParaRPr lang="en-US" sz="2000" dirty="0"/>
           </a:p>
           <a:p>
             <a:pPr marL="342900" indent="-342900" fontAlgn="base">
@@ -11219,7 +11211,20 @@
               <a:buChar char="•"/>
             </a:pPr>
             <a:r>
-              <a:rPr lang="en-US" sz="2000"/>
+              <a:rPr lang="en-US" sz="2000" dirty="0"/>
+              <a:t>In October 2024, invitation sent to CRDCN researchers to opt into data or policy circles. </a:t>
+            </a:r>
+          </a:p>
+          <a:p>
+            <a:pPr marL="342900" indent="-342900" fontAlgn="base">
+              <a:spcAft>
+                <a:spcPts val="600"/>
+              </a:spcAft>
+              <a:buFont typeface="Arial" panose="020B0604020202020204" pitchFamily="34" charset="0"/>
+              <a:buChar char="•"/>
+            </a:pPr>
+            <a:r>
+              <a:rPr lang="en-US" sz="2000" dirty="0"/>
               <a:t>Top research disciplines of respondents: economics, epidemiology, sociology, demography, and public health. CRDCN will be hosting policy circles in the fall of 2025.</a:t>
             </a:r>
           </a:p>
@@ -11232,16 +11237,28 @@
               <a:buChar char="•"/>
             </a:pPr>
             <a:r>
-              <a:rPr lang="en-US" sz="2000"/>
+              <a:rPr lang="en-US" sz="2000" dirty="0"/>
               <a:t>Data circles: </a:t>
             </a:r>
             <a:r>
-              <a:rPr lang="en-US" sz="2000" b="0" i="0">
+              <a:rPr lang="en-US" sz="2000" b="0" i="0" dirty="0">
                 <a:effectLst/>
               </a:rPr>
-              <a:t>Census, Canadian Community Health Survey (CCHS), Longitudinal Immigration Database (IMDB), Education and Labour Market Longitudinal Platform (ELMLP), and the Longitudinal Administrative Databank (LAD). </a:t>
-            </a:r>
-            <a:endParaRPr lang="en-US" sz="2000"/>
+              <a:t>Census, Canadian Community Health Survey (CCHS), Longitudinal Immigration Database (IMDB), Education and </a:t>
+            </a:r>
+            <a:r>
+              <a:rPr lang="en-US" sz="2000" b="0" i="0" dirty="0" err="1">
+                <a:effectLst/>
+              </a:rPr>
+              <a:t>Labour</a:t>
+            </a:r>
+            <a:r>
+              <a:rPr lang="en-US" sz="2000" b="0" i="0" dirty="0">
+                <a:effectLst/>
+              </a:rPr>
+              <a:t> Market Longitudinal Platform (ELMLP), and the Longitudinal Administrative Databank (LAD). </a:t>
+            </a:r>
+            <a:endParaRPr lang="en-US" sz="2000" dirty="0"/>
           </a:p>
           <a:p>
             <a:pPr fontAlgn="base">
@@ -11250,7 +11267,7 @@
               </a:spcAft>
             </a:pPr>
             <a:r>
-              <a:rPr lang="en-US" sz="2000" b="1"/>
+              <a:rPr lang="en-US" sz="2000" b="1" dirty="0"/>
               <a:t>Research collaboration circles</a:t>
             </a:r>
           </a:p>
@@ -11263,7 +11280,7 @@
               <a:buChar char="§"/>
             </a:pPr>
             <a:r>
-              <a:rPr lang="en-US" sz="2000"/>
+              <a:rPr lang="en-US" sz="2000" dirty="0"/>
               <a:t>In December 2025, CRDCN will be inviting researchers to opt into research collaboration circles based on interest expressed by the CRDCN research community.</a:t>
             </a:r>
           </a:p>
@@ -11275,7 +11292,7 @@
               <a:buFont typeface="Wingdings" panose="05000000000000000000" pitchFamily="2" charset="2"/>
               <a:buChar char="§"/>
             </a:pPr>
-            <a:endParaRPr lang="en-US" sz="2000"/>
+            <a:endParaRPr lang="en-US" sz="2000" dirty="0"/>
           </a:p>
           <a:p>
             <a:pPr marL="342900" indent="-342900">
@@ -11285,7 +11302,7 @@
               <a:buFont typeface="Wingdings" panose="05000000000000000000" pitchFamily="2" charset="2"/>
               <a:buChar char="§"/>
             </a:pPr>
-            <a:endParaRPr lang="en-US" sz="2000"/>
+            <a:endParaRPr lang="en-US" sz="2000" dirty="0"/>
           </a:p>
           <a:p>
             <a:pPr marL="342900" indent="-342900" fontAlgn="base">
@@ -11295,7 +11312,7 @@
               <a:buFont typeface="Wingdings" panose="05000000000000000000" pitchFamily="2" charset="2"/>
               <a:buChar char="§"/>
             </a:pPr>
-            <a:endParaRPr lang="en-US"/>
+            <a:endParaRPr lang="en-US" dirty="0"/>
           </a:p>
         </p:txBody>
       </p:sp>
@@ -11339,12 +11356,20 @@
               <a:t>Question to the group: </a:t>
             </a:r>
             <a:r>
+              <a:rPr lang="en-US" sz="2000" dirty="0">
+                <a:solidFill>
+                  <a:srgbClr val="63656A"/>
+                </a:solidFill>
+              </a:rPr>
+              <a:t>Are</a:t>
+            </a:r>
+            <a:r>
               <a:rPr lang="en-US" sz="2000">
                 <a:solidFill>
                   <a:srgbClr val="63656A"/>
                 </a:solidFill>
               </a:rPr>
-              <a:t>What research, policy or data circles would be of interest to you? </a:t>
+              <a:t> research, policy or data circles would be of interest to you? </a:t>
             </a:r>
             <a:endParaRPr lang="en-US" sz="2000"/>
           </a:p>
@@ -11939,8 +11964,8 @@
         </p:nvSpPr>
         <p:spPr>
           <a:xfrm>
-            <a:off x="1005840" y="1204807"/>
-            <a:ext cx="10213912" cy="4932119"/>
+            <a:off x="468630" y="1204807"/>
+            <a:ext cx="11723370" cy="4193456"/>
           </a:xfrm>
           <a:prstGeom prst="rect">
             <a:avLst/>
@@ -11959,7 +11984,7 @@
               </a:spcAft>
             </a:pPr>
             <a:r>
-              <a:rPr lang="en-US" sz="3200" b="1">
+              <a:rPr lang="en-US" sz="3200" b="1" dirty="0">
                 <a:solidFill>
                   <a:schemeClr val="accent1"/>
                 </a:solidFill>
@@ -11968,7 +11993,7 @@
               </a:rPr>
               <a:t>Hearing further from you </a:t>
             </a:r>
-            <a:endParaRPr lang="en-US">
+            <a:endParaRPr lang="en-US" dirty="0">
               <a:solidFill>
                 <a:schemeClr val="accent1"/>
               </a:solidFill>
@@ -11979,11 +12004,11 @@
           <a:p>
             <a:pPr>
               <a:spcAft>
-                <a:spcPts val="300"/>
+                <a:spcPts val="1200"/>
               </a:spcAft>
             </a:pPr>
             <a:r>
-              <a:rPr lang="en-US" sz="2400">
+              <a:rPr lang="en-US" sz="2400" dirty="0">
                 <a:solidFill>
                   <a:schemeClr val="accent1"/>
                 </a:solidFill>
@@ -11992,15 +12017,8 @@
               </a:rPr>
               <a:t>For policy colleagues – </a:t>
             </a:r>
-          </a:p>
-          <a:p>
-            <a:pPr>
-              <a:spcAft>
-                <a:spcPts val="1800"/>
-              </a:spcAft>
-            </a:pPr>
-            <a:r>
-              <a:rPr lang="en-US" sz="2400" i="1">
+            <a:r>
+              <a:rPr lang="en-US" sz="2400" i="1" dirty="0">
                 <a:latin typeface="Arial"/>
                 <a:cs typeface="Arial"/>
               </a:rPr>
@@ -12010,11 +12028,11 @@
           <a:p>
             <a:pPr>
               <a:spcAft>
-                <a:spcPts val="300"/>
+                <a:spcPts val="1200"/>
               </a:spcAft>
             </a:pPr>
             <a:r>
-              <a:rPr lang="en-US" sz="2400">
+              <a:rPr lang="en-US" sz="2400" dirty="0">
                 <a:solidFill>
                   <a:schemeClr val="accent1"/>
                 </a:solidFill>
@@ -12023,15 +12041,8 @@
               </a:rPr>
               <a:t>For CRDCN researchers – </a:t>
             </a:r>
-          </a:p>
-          <a:p>
-            <a:pPr>
-              <a:spcAft>
-                <a:spcPts val="1800"/>
-              </a:spcAft>
-            </a:pPr>
-            <a:r>
-              <a:rPr lang="en-US" sz="2400" i="1">
+            <a:r>
+              <a:rPr lang="en-US" sz="2400" i="1" dirty="0">
                 <a:latin typeface="Arial"/>
                 <a:cs typeface="Arial"/>
               </a:rPr>
@@ -12045,7 +12056,7 @@
               </a:spcAft>
             </a:pPr>
             <a:r>
-              <a:rPr lang="en-US" sz="2400">
+              <a:rPr lang="en-US" sz="2400" dirty="0">
                 <a:solidFill>
                   <a:schemeClr val="accent1"/>
                 </a:solidFill>
@@ -12054,48 +12065,173 @@
               </a:rPr>
               <a:t>For all of us – </a:t>
             </a:r>
-          </a:p>
-          <a:p>
-            <a:pPr>
-              <a:spcAft>
-                <a:spcPts val="600"/>
-              </a:spcAft>
-            </a:pPr>
-            <a:r>
-              <a:rPr lang="en-US" sz="2400" i="1">
+            <a:r>
+              <a:rPr lang="en-US" sz="2400" i="1" dirty="0">
                 <a:latin typeface="Arial"/>
                 <a:cs typeface="Arial"/>
               </a:rPr>
-              <a:t>What can we collectively put into motion to address shared priorities?</a:t>
+              <a:t>What can we collectively put into motion to address shared priorities? What CRDCN-facilitated connections would be valuable to you?   </a:t>
             </a:r>
           </a:p>
           <a:p>
             <a:pPr>
               <a:spcAft>
-                <a:spcPts val="1800"/>
+                <a:spcPts val="300"/>
               </a:spcAft>
             </a:pPr>
-            <a:r>
-              <a:rPr lang="en-US" sz="2400" i="1">
+            <a:endParaRPr lang="en-US" sz="2400" i="1" dirty="0">
+              <a:latin typeface="Arial"/>
+              <a:cs typeface="Arial"/>
+            </a:endParaRPr>
+          </a:p>
+          <a:p>
+            <a:pPr>
+              <a:spcAft>
+                <a:spcPts val="300"/>
+              </a:spcAft>
+            </a:pPr>
+            <a:r>
+              <a:rPr lang="en-US" sz="2400" dirty="0">
+                <a:solidFill>
+                  <a:schemeClr val="accent1"/>
+                </a:solidFill>
                 <a:latin typeface="Arial"/>
                 <a:cs typeface="Arial"/>
               </a:rPr>
-              <a:t>What CRDCN-facilitated connections would be valuable to you?   </a:t>
-            </a:r>
-            <a:endParaRPr lang="en-US" sz="3200" i="1">
-              <a:latin typeface="Arial"/>
+              <a:t>Save-the-date</a:t>
+            </a:r>
+            <a:r>
+              <a:rPr lang="en-US" sz="2400" dirty="0">
+                <a:latin typeface="Arial"/>
+                <a:cs typeface="Arial"/>
+              </a:rPr>
+              <a:t> – October 28, 2025 in Toronto</a:t>
+            </a:r>
+          </a:p>
+          <a:p>
+            <a:pPr>
+              <a:spcAft>
+                <a:spcPts val="300"/>
+              </a:spcAft>
+            </a:pPr>
+            <a:r>
+              <a:rPr lang="en-US" sz="2400" i="1" dirty="0">
+                <a:latin typeface="Arial"/>
+                <a:cs typeface="Arial"/>
+              </a:rPr>
+              <a:t>Closing event for the “Opening doors to data” project</a:t>
+            </a:r>
+            <a:endParaRPr lang="en-US" i="1" dirty="0">
+              <a:latin typeface="Arial Nova Light"/>
               <a:cs typeface="Arial"/>
             </a:endParaRPr>
           </a:p>
-          <a:p>
-            <a:pPr>
+        </p:txBody>
+      </p:sp>
+      <p:sp>
+        <p:nvSpPr>
+          <p:cNvPr id="2" name="Rectangle 1">
+            <a:extLst>
+              <a:ext uri="{FF2B5EF4-FFF2-40B4-BE49-F238E27FC236}">
+                <a16:creationId xmlns:a16="http://schemas.microsoft.com/office/drawing/2014/main" id="{296C1C25-028E-422C-7DBC-00AFD80DF8DE}"/>
+              </a:ext>
+            </a:extLst>
+          </p:cNvPr>
+          <p:cNvSpPr>
+            <a:spLocks noChangeArrowheads="1"/>
+          </p:cNvSpPr>
+          <p:nvPr/>
+        </p:nvSpPr>
+        <p:spPr bwMode="auto">
+          <a:xfrm>
+            <a:off x="0" y="0"/>
+            <a:ext cx="12192000" cy="0"/>
+          </a:xfrm>
+          <a:prstGeom prst="rect">
+            <a:avLst/>
+          </a:prstGeom>
+          <a:noFill/>
+          <a:ln>
+            <a:noFill/>
+          </a:ln>
+          <a:effectLst/>
+          <a:extLst>
+            <a:ext uri="{909E8E84-426E-40DD-AFC4-6F175D3DCCD1}">
+              <a14:hiddenFill xmlns:a14="http://schemas.microsoft.com/office/drawing/2010/main">
+                <a:solidFill>
+                  <a:schemeClr val="accent1"/>
+                </a:solidFill>
+              </a14:hiddenFill>
+            </a:ext>
+            <a:ext uri="{91240B29-F687-4F45-9708-019B960494DF}">
+              <a14:hiddenLine xmlns:a14="http://schemas.microsoft.com/office/drawing/2010/main" w="9525">
+                <a:solidFill>
+                  <a:schemeClr val="tx1"/>
+                </a:solidFill>
+                <a:miter lim="800000"/>
+                <a:headEnd/>
+                <a:tailEnd/>
+              </a14:hiddenLine>
+            </a:ext>
+            <a:ext uri="{AF507438-7753-43E0-B8FC-AC1667EBCBE1}">
+              <a14:hiddenEffects xmlns:a14="http://schemas.microsoft.com/office/drawing/2010/main">
+                <a:effectLst>
+                  <a:outerShdw dist="35921" dir="2700000" algn="ctr" rotWithShape="0">
+                    <a:schemeClr val="bg2"/>
+                  </a:outerShdw>
+                </a:effectLst>
+              </a14:hiddenEffects>
+            </a:ext>
+          </a:extLst>
+        </p:spPr>
+        <p:txBody>
+          <a:bodyPr vert="horz" wrap="square" lIns="91440" tIns="45720" rIns="91440" bIns="45720" numCol="1" anchor="ctr" anchorCtr="0" compatLnSpc="1">
+            <a:prstTxWarp prst="textNoShape">
+              <a:avLst/>
+            </a:prstTxWarp>
+            <a:spAutoFit/>
+          </a:bodyPr>
+          <a:lstStyle/>
+          <a:p>
+            <a:pPr marL="0" marR="0" lvl="0" indent="0" algn="l" defTabSz="914400" rtl="0" eaLnBrk="0" fontAlgn="base" latinLnBrk="0" hangingPunct="0">
+              <a:lnSpc>
+                <a:spcPct val="100000"/>
+              </a:lnSpc>
+              <a:spcBef>
+                <a:spcPct val="0"/>
+              </a:spcBef>
               <a:spcAft>
-                <a:spcPts val="1800"/>
+                <a:spcPct val="0"/>
               </a:spcAft>
+              <a:buClrTx/>
+              <a:buSzTx/>
+              <a:buFontTx/>
+              <a:buNone/>
+              <a:tabLst/>
             </a:pPr>
-            <a:endParaRPr lang="en-US">
-              <a:latin typeface="Arial Nova Light"/>
-              <a:cs typeface="Arial"/>
+            <a:r>
+              <a:rPr kumimoji="0" lang="en-US" altLang="en-US" sz="1800" b="0" i="0" u="none" strike="noStrike" cap="none" normalizeH="0" baseline="0">
+                <a:ln>
+                  <a:noFill/>
+                </a:ln>
+                <a:solidFill>
+                  <a:schemeClr val="tx1"/>
+                </a:solidFill>
+                <a:effectLst/>
+                <a:latin typeface="Arial" panose="020B0604020202020204" pitchFamily="34" charset="0"/>
+                <a:hlinkClick r:id="rId2"/>
+              </a:rPr>
+              <a:t>deck shared earlier with Pascale.pptx</a:t>
+            </a:r>
+            <a:endParaRPr kumimoji="0" lang="en-US" altLang="en-US" sz="1800" b="0" i="0" u="none" strike="noStrike" cap="none" normalizeH="0" baseline="0">
+              <a:ln>
+                <a:noFill/>
+              </a:ln>
+              <a:solidFill>
+                <a:schemeClr val="tx1"/>
+              </a:solidFill>
+              <a:effectLst/>
+              <a:latin typeface="Arial" panose="020B0604020202020204" pitchFamily="34" charset="0"/>
             </a:endParaRPr>
           </a:p>
         </p:txBody>
@@ -12173,20 +12309,20 @@
               </a:spcAft>
             </a:pPr>
             <a:r>
-              <a:rPr lang="en-US" sz="3200" b="1">
+              <a:rPr lang="en-US" sz="3200" b="1" dirty="0">
                 <a:solidFill>
                   <a:schemeClr val="accent1"/>
                 </a:solidFill>
-                <a:latin typeface="Arial" panose="020B0604020202020204" pitchFamily="34" charset="0"/>
+                <a:latin typeface="Arial"/>
                 <a:ea typeface="+mn-lt"/>
-                <a:cs typeface="Arial" panose="020B0604020202020204" pitchFamily="34" charset="0"/>
+                <a:cs typeface="Arial"/>
               </a:rPr>
               <a:t>Thank you</a:t>
             </a:r>
           </a:p>
           <a:p>
             <a:r>
-              <a:rPr lang="en-US" sz="2000" b="1"/>
+              <a:rPr lang="en-US" sz="2000" b="1" dirty="0"/>
               <a:t>Contact me if you have questions or ideas about future collaboration:</a:t>
             </a:r>
           </a:p>
@@ -12199,20 +12335,23 @@
               <a:rPr lang="en-US" sz="2000">
                 <a:cs typeface="Arial"/>
               </a:rPr>
-              <a:t>çal, Director</a:t>
-            </a:r>
-          </a:p>
-          <a:p>
-            <a:r>
-              <a:rPr lang="en-US" sz="2000">
+              <a:t>çal</a:t>
+            </a:r>
+          </a:p>
+          <a:p>
+            <a:r>
+              <a:rPr lang="en-US" sz="2000" dirty="0">
                 <a:cs typeface="Arial"/>
               </a:rPr>
-              <a:t>Research, Training and Knowledge Mobilization</a:t>
-            </a:r>
-          </a:p>
-          <a:p>
-            <a:r>
-              <a:rPr lang="en-US" sz="2000">
+              <a:t>Director of Research, Training and Knowledge Mobilization</a:t>
+            </a:r>
+            <a:endParaRPr lang="en-US" dirty="0">
+              <a:cs typeface="Arial"/>
+            </a:endParaRPr>
+          </a:p>
+          <a:p>
+            <a:r>
+              <a:rPr lang="en-US" sz="2000" dirty="0">
                 <a:cs typeface="Arial"/>
               </a:rPr>
               <a:t>Canadian Research Data Centre Network</a:t>
@@ -12220,22 +12359,22 @@
           </a:p>
           <a:p>
             <a:r>
-              <a:rPr lang="en-US" sz="2000">
+              <a:rPr lang="en-US" sz="2000" dirty="0">
                 <a:cs typeface="Arial"/>
               </a:rPr>
               <a:t> </a:t>
             </a:r>
             <a:r>
-              <a:rPr lang="en-US" sz="2000">
+              <a:rPr lang="en-US" sz="2000" dirty="0">
                 <a:hlinkClick r:id="rId2"/>
               </a:rPr>
               <a:t>johanne.provencal@crdcn.ca</a:t>
             </a:r>
             <a:r>
-              <a:rPr lang="en-US" sz="2000"/>
+              <a:rPr lang="en-US" sz="2000" dirty="0"/>
               <a:t> </a:t>
             </a:r>
-            <a:endParaRPr lang="en-US" sz="2000">
+            <a:endParaRPr lang="en-US" sz="2000" dirty="0">
               <a:ea typeface="+mn-lt"/>
               <a:cs typeface="Arial" panose="020B0604020202020204" pitchFamily="34" charset="0"/>
             </a:endParaRPr>
@@ -12939,7 +13078,7 @@
               </a:spcAft>
             </a:pPr>
             <a:r>
-              <a:rPr lang="en-US" sz="3200" b="1">
+              <a:rPr lang="en-US" sz="3200" b="1" dirty="0">
                 <a:solidFill>
                   <a:schemeClr val="accent1"/>
                 </a:solidFill>
@@ -12964,7 +13103,7 @@
               <a:buAutoNum type="arabicPeriod"/>
             </a:pPr>
             <a:r>
-              <a:rPr lang="en-US" sz="2400"/>
+              <a:rPr lang="en-US" sz="2400" dirty="0"/>
               <a:t>Who we have in the room today</a:t>
             </a:r>
           </a:p>
@@ -12976,7 +13115,7 @@
               <a:buAutoNum type="arabicPeriod"/>
             </a:pPr>
             <a:r>
-              <a:rPr lang="en-US" sz="2400"/>
+              <a:rPr lang="en-US" sz="2400" dirty="0"/>
               <a:t>CRDCN – who we are as a Network and what we do</a:t>
             </a:r>
           </a:p>
@@ -12988,7 +13127,7 @@
               <a:buAutoNum type="arabicPeriod"/>
             </a:pPr>
             <a:r>
-              <a:rPr lang="en-US" sz="2400"/>
+              <a:rPr lang="en-US" sz="2400" dirty="0"/>
               <a:t>CRDCN research informing policy – examples</a:t>
             </a:r>
           </a:p>
@@ -13000,7 +13139,7 @@
               <a:buAutoNum type="arabicPeriod"/>
             </a:pPr>
             <a:r>
-              <a:rPr lang="en-US" sz="2400"/>
+              <a:rPr lang="en-US" sz="2400" dirty="0"/>
               <a:t>CRDCN – mechanisms to connect research and policy</a:t>
             </a:r>
           </a:p>
@@ -13012,8 +13151,8 @@
               <a:buAutoNum type="arabicPeriod"/>
             </a:pPr>
             <a:r>
-              <a:rPr lang="en-US" sz="2400"/>
-              <a:t>Hearing from you </a:t>
+              <a:rPr lang="en-US" sz="2400" dirty="0"/>
+              <a:t>Hearing from you – and the event October 28, 2025</a:t>
             </a:r>
           </a:p>
           <a:p>
@@ -13226,7 +13365,15 @@
             </a:r>
             <a:r>
               <a:rPr lang="en-US" sz="2000"/>
-              <a:t>: Please briefly introduce yourself.</a:t>
+              <a:t>: Please </a:t>
+            </a:r>
+            <a:r>
+              <a:rPr lang="en-US" sz="2000" dirty="0"/>
+              <a:t>let us know your sector of work and/or </a:t>
+            </a:r>
+            <a:r>
+              <a:rPr lang="en-US" sz="2000"/>
+              <a:t>briefly introduce yourself.</a:t>
             </a:r>
             <a:endParaRPr lang="en-US"/>
           </a:p>
@@ -17117,6 +17264,26 @@
 </file>
 
 <file path=customXml/item2.xml><?xml version="1.0" encoding="utf-8"?>
+<p:properties xmlns:p="http://schemas.microsoft.com/office/2006/metadata/properties" xmlns:xsi="http://www.w3.org/2001/XMLSchema-instance" xmlns:pc="http://schemas.microsoft.com/office/infopath/2007/PartnerControls">
+  <documentManagement>
+    <SharedWithUsers xmlns="e471432c-39b5-4e37-b6a1-0303f55f1001">
+      <UserInfo>
+        <DisplayName/>
+        <AccountId xsi:nil="true"/>
+        <AccountType/>
+      </UserInfo>
+    </SharedWithUsers>
+    <lcf76f155ced4ddcb4097134ff3c332f xmlns="fe770d8f-5db2-42ab-9109-2ccfbb694cc3">
+      <Terms xmlns="http://schemas.microsoft.com/office/infopath/2007/PartnerControls"/>
+    </lcf76f155ced4ddcb4097134ff3c332f>
+    <TaxCatchAll xmlns="e471432c-39b5-4e37-b6a1-0303f55f1001" xsi:nil="true"/>
+    <_Flow_SignoffStatus xmlns="fe770d8f-5db2-42ab-9109-2ccfbb694cc3" xsi:nil="true"/>
+    <MediaLengthInSeconds xmlns="fe770d8f-5db2-42ab-9109-2ccfbb694cc3" xsi:nil="true"/>
+  </documentManagement>
+</p:properties>
+</file>
+
+<file path=customXml/item3.xml><?xml version="1.0" encoding="utf-8"?>
 <ct:contentTypeSchema xmlns:ct="http://schemas.microsoft.com/office/2006/metadata/contentType" xmlns:ma="http://schemas.microsoft.com/office/2006/metadata/properties/metaAttributes" ct:_="" ma:_="" ma:contentTypeName="Document" ma:contentTypeID="0x010100A3999F3824AACA4CB5C02CA1B5B2DFAE" ma:contentTypeVersion="19" ma:contentTypeDescription="Create a new document." ma:contentTypeScope="" ma:versionID="28208ec1fa8993488d2f37d519b62a51">
   <xsd:schema xmlns:xsd="http://www.w3.org/2001/XMLSchema" xmlns:xs="http://www.w3.org/2001/XMLSchema" xmlns:p="http://schemas.microsoft.com/office/2006/metadata/properties" xmlns:ns2="fe770d8f-5db2-42ab-9109-2ccfbb694cc3" xmlns:ns3="e471432c-39b5-4e37-b6a1-0303f55f1001" targetNamespace="http://schemas.microsoft.com/office/2006/metadata/properties" ma:root="true" ma:fieldsID="c5479fc8bf5eba5a8f754de72ea1b178" ns2:_="" ns3:_="">
     <xsd:import namespace="fe770d8f-5db2-42ab-9109-2ccfbb694cc3"/>
@@ -17377,26 +17544,6 @@
 </ct:contentTypeSchema>
 </file>
 
-<file path=customXml/item3.xml><?xml version="1.0" encoding="utf-8"?>
-<p:properties xmlns:p="http://schemas.microsoft.com/office/2006/metadata/properties" xmlns:xsi="http://www.w3.org/2001/XMLSchema-instance" xmlns:pc="http://schemas.microsoft.com/office/infopath/2007/PartnerControls">
-  <documentManagement>
-    <SharedWithUsers xmlns="e471432c-39b5-4e37-b6a1-0303f55f1001">
-      <UserInfo>
-        <DisplayName/>
-        <AccountId xsi:nil="true"/>
-        <AccountType/>
-      </UserInfo>
-    </SharedWithUsers>
-    <lcf76f155ced4ddcb4097134ff3c332f xmlns="fe770d8f-5db2-42ab-9109-2ccfbb694cc3">
-      <Terms xmlns="http://schemas.microsoft.com/office/infopath/2007/PartnerControls"/>
-    </lcf76f155ced4ddcb4097134ff3c332f>
-    <TaxCatchAll xmlns="e471432c-39b5-4e37-b6a1-0303f55f1001" xsi:nil="true"/>
-    <_Flow_SignoffStatus xmlns="fe770d8f-5db2-42ab-9109-2ccfbb694cc3" xsi:nil="true"/>
-    <MediaLengthInSeconds xmlns="fe770d8f-5db2-42ab-9109-2ccfbb694cc3" xsi:nil="true"/>
-  </documentManagement>
-</p:properties>
-</file>
-
 <file path=customXml/itemProps1.xml><?xml version="1.0" encoding="utf-8"?>
 <ds:datastoreItem xmlns:ds="http://schemas.openxmlformats.org/officeDocument/2006/customXml" ds:itemID="{6BA29483-5E78-4541-AD2D-42735FF9999B}">
   <ds:schemaRefs>
@@ -17406,6 +17553,23 @@
 </file>
 
 <file path=customXml/itemProps2.xml><?xml version="1.0" encoding="utf-8"?>
+<ds:datastoreItem xmlns:ds="http://schemas.openxmlformats.org/officeDocument/2006/customXml" ds:itemID="{555E7EBE-8F52-41E7-AED3-CEA8B1FA5B00}">
+  <ds:schemaRefs>
+    <ds:schemaRef ds:uri="http://purl.org/dc/elements/1.1/"/>
+    <ds:schemaRef ds:uri="http://purl.org/dc/dcmitype/"/>
+    <ds:schemaRef ds:uri="http://purl.org/dc/terms/"/>
+    <ds:schemaRef ds:uri="e471432c-39b5-4e37-b6a1-0303f55f1001"/>
+    <ds:schemaRef ds:uri="http://schemas.microsoft.com/office/2006/documentManagement/types"/>
+    <ds:schemaRef ds:uri="http://www.w3.org/XML/1998/namespace"/>
+    <ds:schemaRef ds:uri="http://schemas.microsoft.com/office/2006/metadata/properties"/>
+    <ds:schemaRef ds:uri="http://schemas.microsoft.com/office/infopath/2007/PartnerControls"/>
+    <ds:schemaRef ds:uri="http://schemas.openxmlformats.org/package/2006/metadata/core-properties"/>
+    <ds:schemaRef ds:uri="fe770d8f-5db2-42ab-9109-2ccfbb694cc3"/>
+  </ds:schemaRefs>
+</ds:datastoreItem>
+</file>
+
+<file path=customXml/itemProps3.xml><?xml version="1.0" encoding="utf-8"?>
 <ds:datastoreItem xmlns:ds="http://schemas.openxmlformats.org/officeDocument/2006/customXml" ds:itemID="{860D43AB-1C14-4844-BC2B-3ABC7F98AA35}">
   <ds:schemaRefs>
     <ds:schemaRef ds:uri="e471432c-39b5-4e37-b6a1-0303f55f1001"/>
@@ -17422,21 +17586,4 @@
     <ds:schemaRef ds:uri="http://www.w3.org/2001/XMLSchema"/>
   </ds:schemaRefs>
 </ds:datastoreItem>
-</file>
-
-<file path=customXml/itemProps3.xml><?xml version="1.0" encoding="utf-8"?>
-<ds:datastoreItem xmlns:ds="http://schemas.openxmlformats.org/officeDocument/2006/customXml" ds:itemID="{555E7EBE-8F52-41E7-AED3-CEA8B1FA5B00}">
-  <ds:schemaRefs>
-    <ds:schemaRef ds:uri="http://schemas.microsoft.com/office/infopath/2007/PartnerControls"/>
-    <ds:schemaRef ds:uri="fe770d8f-5db2-42ab-9109-2ccfbb694cc3"/>
-    <ds:schemaRef ds:uri="http://schemas.openxmlformats.org/package/2006/metadata/core-properties"/>
-    <ds:schemaRef ds:uri="http://schemas.microsoft.com/office/2006/documentManagement/types"/>
-    <ds:schemaRef ds:uri="http://purl.org/dc/terms/"/>
-    <ds:schemaRef ds:uri="http://purl.org/dc/elements/1.1/"/>
-    <ds:schemaRef ds:uri="e471432c-39b5-4e37-b6a1-0303f55f1001"/>
-    <ds:schemaRef ds:uri="http://schemas.microsoft.com/office/2006/metadata/properties"/>
-    <ds:schemaRef ds:uri="http://www.w3.org/XML/1998/namespace"/>
-    <ds:schemaRef ds:uri="http://purl.org/dc/dcmitype/"/>
-  </ds:schemaRefs>
-</ds:datastoreItem>
 </file>
</xml_diff>